<commit_message>
Recreations: Ethics pie charts + master logo once; refresh AUDIT.md
</commit_message>
<xml_diff>
--- a/examples/recreations/03_Box_Secretary__ArtNonprofit_Info_Planning_Meeting_20201220/out_mat2ppt.pptx
+++ b/examples/recreations/03_Box_Secretary__ArtNonprofit_Info_Planning_Meeting_20201220/out_mat2ppt.pptx
@@ -3242,57 +3242,9 @@
         <p:nvPr/>
       </p:nvGrpSpPr>
       <p:grpSpPr/>
-      <p:pic>
-        <p:nvPicPr>
-          <p:cNvPr id="2" name="Picture 1" descr="image2.jpeg"/>
-          <p:cNvPicPr>
-            <a:picLocks noChangeAspect="1"/>
-          </p:cNvPicPr>
-          <p:nvPr/>
-        </p:nvPicPr>
-        <p:blipFill>
-          <a:blip r:embed="rId2"/>
-          <a:stretch>
-            <a:fillRect/>
-          </a:stretch>
-        </p:blipFill>
-        <p:spPr>
-          <a:xfrm>
-            <a:off x="188120" y="5525929"/>
-            <a:ext cx="1143000" cy="1224229"/>
-          </a:xfrm>
-          <a:prstGeom prst="rect">
-            <a:avLst/>
-          </a:prstGeom>
-        </p:spPr>
-      </p:pic>
-      <p:pic>
-        <p:nvPicPr>
-          <p:cNvPr id="3" name="Picture 2" descr="image3.jpg"/>
-          <p:cNvPicPr>
-            <a:picLocks noChangeAspect="1"/>
-          </p:cNvPicPr>
-          <p:nvPr/>
-        </p:nvPicPr>
-        <p:blipFill>
-          <a:blip r:embed="rId3"/>
-          <a:stretch>
-            <a:fillRect/>
-          </a:stretch>
-        </p:blipFill>
-        <p:spPr>
-          <a:xfrm>
-            <a:off x="10638881" y="139366"/>
-            <a:ext cx="1410420" cy="1371600"/>
-          </a:xfrm>
-          <a:prstGeom prst="rect">
-            <a:avLst/>
-          </a:prstGeom>
-        </p:spPr>
-      </p:pic>
-      <p:sp>
-        <p:nvSpPr>
-          <p:cNvPr id="4" name="Rectangle 3"/>
+      <p:sp>
+        <p:nvSpPr>
+          <p:cNvPr id="2" name="Rectangle 1"/>
           <p:cNvSpPr/>
           <p:nvPr/>
         </p:nvSpPr>
@@ -3347,57 +3299,9 @@
         <p:nvPr/>
       </p:nvGrpSpPr>
       <p:grpSpPr/>
-      <p:pic>
-        <p:nvPicPr>
-          <p:cNvPr id="2" name="Picture 1" descr="image2.jpeg"/>
-          <p:cNvPicPr>
-            <a:picLocks noChangeAspect="1"/>
-          </p:cNvPicPr>
-          <p:nvPr/>
-        </p:nvPicPr>
-        <p:blipFill>
-          <a:blip r:embed="rId2"/>
-          <a:stretch>
-            <a:fillRect/>
-          </a:stretch>
-        </p:blipFill>
-        <p:spPr>
-          <a:xfrm>
-            <a:off x="188120" y="5525929"/>
-            <a:ext cx="1143000" cy="1224229"/>
-          </a:xfrm>
-          <a:prstGeom prst="rect">
-            <a:avLst/>
-          </a:prstGeom>
-        </p:spPr>
-      </p:pic>
-      <p:pic>
-        <p:nvPicPr>
-          <p:cNvPr id="3" name="Picture 2" descr="image3.jpg"/>
-          <p:cNvPicPr>
-            <a:picLocks noChangeAspect="1"/>
-          </p:cNvPicPr>
-          <p:nvPr/>
-        </p:nvPicPr>
-        <p:blipFill>
-          <a:blip r:embed="rId3"/>
-          <a:stretch>
-            <a:fillRect/>
-          </a:stretch>
-        </p:blipFill>
-        <p:spPr>
-          <a:xfrm>
-            <a:off x="10638881" y="139366"/>
-            <a:ext cx="1410420" cy="1371600"/>
-          </a:xfrm>
-          <a:prstGeom prst="rect">
-            <a:avLst/>
-          </a:prstGeom>
-        </p:spPr>
-      </p:pic>
-      <p:sp>
-        <p:nvSpPr>
-          <p:cNvPr id="4" name="Rectangle 3"/>
+      <p:sp>
+        <p:nvSpPr>
+          <p:cNvPr id="2" name="Rectangle 1"/>
           <p:cNvSpPr/>
           <p:nvPr/>
         </p:nvSpPr>
@@ -3452,57 +3356,9 @@
         <p:nvPr/>
       </p:nvGrpSpPr>
       <p:grpSpPr/>
-      <p:pic>
-        <p:nvPicPr>
-          <p:cNvPr id="2" name="Picture 1" descr="image2.jpeg"/>
-          <p:cNvPicPr>
-            <a:picLocks noChangeAspect="1"/>
-          </p:cNvPicPr>
-          <p:nvPr/>
-        </p:nvPicPr>
-        <p:blipFill>
-          <a:blip r:embed="rId2"/>
-          <a:stretch>
-            <a:fillRect/>
-          </a:stretch>
-        </p:blipFill>
-        <p:spPr>
-          <a:xfrm>
-            <a:off x="188120" y="5525929"/>
-            <a:ext cx="1143000" cy="1224229"/>
-          </a:xfrm>
-          <a:prstGeom prst="rect">
-            <a:avLst/>
-          </a:prstGeom>
-        </p:spPr>
-      </p:pic>
-      <p:pic>
-        <p:nvPicPr>
-          <p:cNvPr id="3" name="Picture 2" descr="image3.jpg"/>
-          <p:cNvPicPr>
-            <a:picLocks noChangeAspect="1"/>
-          </p:cNvPicPr>
-          <p:nvPr/>
-        </p:nvPicPr>
-        <p:blipFill>
-          <a:blip r:embed="rId3"/>
-          <a:stretch>
-            <a:fillRect/>
-          </a:stretch>
-        </p:blipFill>
-        <p:spPr>
-          <a:xfrm>
-            <a:off x="10638881" y="139366"/>
-            <a:ext cx="1410420" cy="1371600"/>
-          </a:xfrm>
-          <a:prstGeom prst="rect">
-            <a:avLst/>
-          </a:prstGeom>
-        </p:spPr>
-      </p:pic>
-      <p:sp>
-        <p:nvSpPr>
-          <p:cNvPr id="4" name="Rectangle 3"/>
+      <p:sp>
+        <p:nvSpPr>
+          <p:cNvPr id="2" name="Rectangle 1"/>
           <p:cNvSpPr/>
           <p:nvPr/>
         </p:nvSpPr>
@@ -3541,7 +3397,7 @@
       </p:sp>
       <p:sp>
         <p:nvSpPr>
-          <p:cNvPr id="5" name="Rectangle 4"/>
+          <p:cNvPr id="3" name="Rectangle 2"/>
           <p:cNvSpPr/>
           <p:nvPr/>
         </p:nvSpPr>
@@ -3596,57 +3452,9 @@
         <p:nvPr/>
       </p:nvGrpSpPr>
       <p:grpSpPr/>
-      <p:pic>
-        <p:nvPicPr>
-          <p:cNvPr id="2" name="Picture 1" descr="image2.jpeg"/>
-          <p:cNvPicPr>
-            <a:picLocks noChangeAspect="1"/>
-          </p:cNvPicPr>
-          <p:nvPr/>
-        </p:nvPicPr>
-        <p:blipFill>
-          <a:blip r:embed="rId2"/>
-          <a:stretch>
-            <a:fillRect/>
-          </a:stretch>
-        </p:blipFill>
-        <p:spPr>
-          <a:xfrm>
-            <a:off x="188120" y="5525929"/>
-            <a:ext cx="1143000" cy="1224229"/>
-          </a:xfrm>
-          <a:prstGeom prst="rect">
-            <a:avLst/>
-          </a:prstGeom>
-        </p:spPr>
-      </p:pic>
-      <p:pic>
-        <p:nvPicPr>
-          <p:cNvPr id="3" name="Picture 2" descr="image3.jpg"/>
-          <p:cNvPicPr>
-            <a:picLocks noChangeAspect="1"/>
-          </p:cNvPicPr>
-          <p:nvPr/>
-        </p:nvPicPr>
-        <p:blipFill>
-          <a:blip r:embed="rId3"/>
-          <a:stretch>
-            <a:fillRect/>
-          </a:stretch>
-        </p:blipFill>
-        <p:spPr>
-          <a:xfrm>
-            <a:off x="10638881" y="139366"/>
-            <a:ext cx="1410420" cy="1371600"/>
-          </a:xfrm>
-          <a:prstGeom prst="rect">
-            <a:avLst/>
-          </a:prstGeom>
-        </p:spPr>
-      </p:pic>
-      <p:sp>
-        <p:nvSpPr>
-          <p:cNvPr id="4" name="Rectangle 3"/>
+      <p:sp>
+        <p:nvSpPr>
+          <p:cNvPr id="2" name="Rectangle 1"/>
           <p:cNvSpPr/>
           <p:nvPr/>
         </p:nvSpPr>
@@ -3685,7 +3493,7 @@
       </p:sp>
       <p:sp>
         <p:nvSpPr>
-          <p:cNvPr id="5" name="Rectangle 4"/>
+          <p:cNvPr id="3" name="Rectangle 2"/>
           <p:cNvSpPr/>
           <p:nvPr/>
         </p:nvSpPr>
@@ -3724,7 +3532,7 @@
       </p:sp>
       <p:sp>
         <p:nvSpPr>
-          <p:cNvPr id="6" name="Rectangle 5"/>
+          <p:cNvPr id="4" name="Rectangle 3"/>
           <p:cNvSpPr/>
           <p:nvPr/>
         </p:nvSpPr>
@@ -3779,9 +3587,87 @@
         <p:nvPr/>
       </p:nvGrpSpPr>
       <p:grpSpPr/>
+      <p:sp>
+        <p:nvSpPr>
+          <p:cNvPr id="2" name="Rectangle 1"/>
+          <p:cNvSpPr/>
+          <p:nvPr/>
+        </p:nvSpPr>
+        <p:spPr>
+          <a:xfrm>
+            <a:off x="493095" y="1226"/>
+            <a:ext cx="10515600" cy="1072559"/>
+          </a:xfrm>
+          <a:prstGeom prst="rect">
+            <a:avLst/>
+          </a:prstGeom>
+        </p:spPr>
+        <p:style>
+          <a:lnRef idx="1">
+            <a:schemeClr val="accent1"/>
+          </a:lnRef>
+          <a:fillRef idx="3">
+            <a:schemeClr val="accent1"/>
+          </a:fillRef>
+          <a:effectRef idx="2">
+            <a:schemeClr val="accent1"/>
+          </a:effectRef>
+          <a:fontRef idx="minor">
+            <a:schemeClr val="lt1"/>
+          </a:fontRef>
+        </p:style>
+        <p:txBody>
+          <a:bodyPr rtlCol="0" anchor="ctr"/>
+          <a:lstStyle/>
+          <a:p>
+            <a:r>
+              <a:t>Mother Seton Hall Art Schema</a:t>
+            </a:r>
+          </a:p>
+        </p:txBody>
+      </p:sp>
+      <p:sp>
+        <p:nvSpPr>
+          <p:cNvPr id="3" name="Rectangle 2"/>
+          <p:cNvSpPr/>
+          <p:nvPr/>
+        </p:nvSpPr>
+        <p:spPr>
+          <a:xfrm>
+            <a:off x="1436528" y="4766554"/>
+            <a:ext cx="2863098" cy="1384625"/>
+          </a:xfrm>
+          <a:prstGeom prst="rect">
+            <a:avLst/>
+          </a:prstGeom>
+        </p:spPr>
+        <p:style>
+          <a:lnRef idx="1">
+            <a:schemeClr val="accent1"/>
+          </a:lnRef>
+          <a:fillRef idx="3">
+            <a:schemeClr val="accent1"/>
+          </a:fillRef>
+          <a:effectRef idx="2">
+            <a:schemeClr val="accent1"/>
+          </a:effectRef>
+          <a:fontRef idx="minor">
+            <a:schemeClr val="lt1"/>
+          </a:fontRef>
+        </p:style>
+        <p:txBody>
+          <a:bodyPr rtlCol="0" anchor="ctr"/>
+          <a:lstStyle/>
+          <a:p>
+            <a:r>
+              <a:t>CompletedIn-progressPlanning Stages</a:t>
+            </a:r>
+          </a:p>
+        </p:txBody>
+      </p:sp>
       <p:pic>
         <p:nvPicPr>
-          <p:cNvPr id="2" name="Picture 1" descr="image2.jpeg"/>
+          <p:cNvPr id="4" name="Picture 3" descr="image4.png"/>
           <p:cNvPicPr>
             <a:picLocks noChangeAspect="1"/>
           </p:cNvPicPr>
@@ -3795,140 +3681,74 @@
         </p:blipFill>
         <p:spPr>
           <a:xfrm>
-            <a:off x="188120" y="5525929"/>
-            <a:ext cx="1143000" cy="1224229"/>
+            <a:off x="707407" y="1155858"/>
+            <a:ext cx="9944387" cy="3686175"/>
           </a:xfrm>
           <a:prstGeom prst="rect">
             <a:avLst/>
           </a:prstGeom>
         </p:spPr>
       </p:pic>
-      <p:pic>
-        <p:nvPicPr>
-          <p:cNvPr id="3" name="Picture 2" descr="image3.jpg"/>
-          <p:cNvPicPr>
-            <a:picLocks noChangeAspect="1"/>
-          </p:cNvPicPr>
+      <p:cxnSp>
+        <p:nvCxnSpPr>
+          <p:cNvPr id="5" name="Connector 4"/>
+          <p:cNvCxnSpPr/>
           <p:nvPr/>
-        </p:nvPicPr>
-        <p:blipFill>
-          <a:blip r:embed="rId3"/>
-          <a:stretch>
-            <a:fillRect/>
-          </a:stretch>
-        </p:blipFill>
-        <p:spPr>
-          <a:xfrm>
-            <a:off x="10638881" y="139366"/>
-            <a:ext cx="1410420" cy="1371600"/>
-          </a:xfrm>
-          <a:prstGeom prst="rect">
+        </p:nvCxnSpPr>
+        <p:spPr>
+          <a:xfrm>
+            <a:off x="856034" y="3196147"/>
+            <a:ext cx="1741251" cy="0"/>
+          </a:xfrm>
+          <a:prstGeom prst="line">
             <a:avLst/>
           </a:prstGeom>
         </p:spPr>
-      </p:pic>
-      <p:sp>
-        <p:nvSpPr>
-          <p:cNvPr id="4" name="Rectangle 3"/>
-          <p:cNvSpPr/>
+        <p:style>
+          <a:lnRef idx="2">
+            <a:schemeClr val="accent1"/>
+          </a:lnRef>
+          <a:fillRef idx="0">
+            <a:schemeClr val="accent1"/>
+          </a:fillRef>
+          <a:effectRef idx="1">
+            <a:schemeClr val="accent1"/>
+          </a:effectRef>
+          <a:fontRef idx="minor">
+            <a:schemeClr val="tx1"/>
+          </a:fontRef>
+        </p:style>
+      </p:cxnSp>
+      <p:cxnSp>
+        <p:nvCxnSpPr>
+          <p:cNvPr id="6" name="Connector 5"/>
+          <p:cNvCxnSpPr/>
           <p:nvPr/>
-        </p:nvSpPr>
-        <p:spPr>
-          <a:xfrm>
-            <a:off x="493095" y="1226"/>
-            <a:ext cx="10515600" cy="1072559"/>
-          </a:xfrm>
-          <a:prstGeom prst="rect">
+        </p:nvCxnSpPr>
+        <p:spPr>
+          <a:xfrm>
+            <a:off x="2908571" y="3225331"/>
+            <a:ext cx="2423959" cy="0"/>
+          </a:xfrm>
+          <a:prstGeom prst="line">
             <a:avLst/>
           </a:prstGeom>
         </p:spPr>
         <p:style>
-          <a:lnRef idx="1">
+          <a:lnRef idx="2">
             <a:schemeClr val="accent1"/>
           </a:lnRef>
-          <a:fillRef idx="3">
+          <a:fillRef idx="0">
             <a:schemeClr val="accent1"/>
           </a:fillRef>
-          <a:effectRef idx="2">
+          <a:effectRef idx="1">
             <a:schemeClr val="accent1"/>
           </a:effectRef>
           <a:fontRef idx="minor">
-            <a:schemeClr val="lt1"/>
+            <a:schemeClr val="tx1"/>
           </a:fontRef>
         </p:style>
-        <p:txBody>
-          <a:bodyPr rtlCol="0" anchor="ctr"/>
-          <a:lstStyle/>
-          <a:p>
-            <a:r>
-              <a:t>Mother Seton Hall Art Schema</a:t>
-            </a:r>
-          </a:p>
-        </p:txBody>
-      </p:sp>
-      <p:sp>
-        <p:nvSpPr>
-          <p:cNvPr id="5" name="Rectangle 4"/>
-          <p:cNvSpPr/>
-          <p:nvPr/>
-        </p:nvSpPr>
-        <p:spPr>
-          <a:xfrm>
-            <a:off x="1436528" y="4766554"/>
-            <a:ext cx="2863098" cy="1384625"/>
-          </a:xfrm>
-          <a:prstGeom prst="rect">
-            <a:avLst/>
-          </a:prstGeom>
-        </p:spPr>
-        <p:style>
-          <a:lnRef idx="1">
-            <a:schemeClr val="accent1"/>
-          </a:lnRef>
-          <a:fillRef idx="3">
-            <a:schemeClr val="accent1"/>
-          </a:fillRef>
-          <a:effectRef idx="2">
-            <a:schemeClr val="accent1"/>
-          </a:effectRef>
-          <a:fontRef idx="minor">
-            <a:schemeClr val="lt1"/>
-          </a:fontRef>
-        </p:style>
-        <p:txBody>
-          <a:bodyPr rtlCol="0" anchor="ctr"/>
-          <a:lstStyle/>
-          <a:p>
-            <a:r>
-              <a:t>CompletedIn-progressPlanning Stages</a:t>
-            </a:r>
-          </a:p>
-        </p:txBody>
-      </p:sp>
-      <p:pic>
-        <p:nvPicPr>
-          <p:cNvPr id="6" name="Picture 5" descr="image4.png"/>
-          <p:cNvPicPr>
-            <a:picLocks noChangeAspect="1"/>
-          </p:cNvPicPr>
-          <p:nvPr/>
-        </p:nvPicPr>
-        <p:blipFill>
-          <a:blip r:embed="rId4"/>
-          <a:stretch>
-            <a:fillRect/>
-          </a:stretch>
-        </p:blipFill>
-        <p:spPr>
-          <a:xfrm>
-            <a:off x="707407" y="1155858"/>
-            <a:ext cx="9944387" cy="3686175"/>
-          </a:xfrm>
-          <a:prstGeom prst="rect">
-            <a:avLst/>
-          </a:prstGeom>
-        </p:spPr>
-      </p:pic>
+      </p:cxnSp>
       <p:cxnSp>
         <p:nvCxnSpPr>
           <p:cNvPr id="7" name="Connector 6"/>
@@ -3937,7 +3757,7 @@
         </p:nvCxnSpPr>
         <p:spPr>
           <a:xfrm>
-            <a:off x="856034" y="3196147"/>
+            <a:off x="856034" y="2755158"/>
             <a:ext cx="1741251" cy="0"/>
           </a:xfrm>
           <a:prstGeom prst="line">
@@ -3967,8 +3787,8 @@
         </p:nvCxnSpPr>
         <p:spPr>
           <a:xfrm>
-            <a:off x="2908571" y="3225331"/>
-            <a:ext cx="2423959" cy="0"/>
+            <a:off x="856033" y="4026238"/>
+            <a:ext cx="787941" cy="0"/>
           </a:xfrm>
           <a:prstGeom prst="line">
             <a:avLst/>
@@ -3996,9 +3816,9 @@
           <p:nvPr/>
         </p:nvCxnSpPr>
         <p:spPr>
-          <a:xfrm>
-            <a:off x="856034" y="2755158"/>
-            <a:ext cx="1741251" cy="0"/>
+          <a:xfrm flipV="1">
+            <a:off x="875488" y="3196147"/>
+            <a:ext cx="1" cy="806380"/>
           </a:xfrm>
           <a:prstGeom prst="line">
             <a:avLst/>
@@ -4027,8 +3847,8 @@
         </p:nvCxnSpPr>
         <p:spPr>
           <a:xfrm>
-            <a:off x="856033" y="4026238"/>
-            <a:ext cx="787941" cy="0"/>
+            <a:off x="5332530" y="3338820"/>
+            <a:ext cx="418364" cy="0"/>
           </a:xfrm>
           <a:prstGeom prst="line">
             <a:avLst/>
@@ -4056,9 +3876,9 @@
           <p:nvPr/>
         </p:nvCxnSpPr>
         <p:spPr>
-          <a:xfrm flipV="1">
-            <a:off x="875488" y="3196147"/>
-            <a:ext cx="1" cy="806380"/>
+          <a:xfrm>
+            <a:off x="2908571" y="2776845"/>
+            <a:ext cx="2423959" cy="0"/>
           </a:xfrm>
           <a:prstGeom prst="line">
             <a:avLst/>
@@ -4087,8 +3907,8 @@
         </p:nvCxnSpPr>
         <p:spPr>
           <a:xfrm>
-            <a:off x="5332530" y="3338820"/>
-            <a:ext cx="418364" cy="0"/>
+            <a:off x="5658256" y="2776845"/>
+            <a:ext cx="2201693" cy="0"/>
           </a:xfrm>
           <a:prstGeom prst="line">
             <a:avLst/>
@@ -4117,8 +3937,8 @@
         </p:nvCxnSpPr>
         <p:spPr>
           <a:xfrm>
-            <a:off x="2908571" y="2776845"/>
-            <a:ext cx="2423959" cy="0"/>
+            <a:off x="6066816" y="3197366"/>
+            <a:ext cx="1773677" cy="0"/>
           </a:xfrm>
           <a:prstGeom prst="line">
             <a:avLst/>
@@ -4147,8 +3967,8 @@
         </p:nvCxnSpPr>
         <p:spPr>
           <a:xfrm>
-            <a:off x="5658256" y="2776845"/>
-            <a:ext cx="2201693" cy="0"/>
+            <a:off x="8164749" y="3205875"/>
+            <a:ext cx="2175753" cy="0"/>
           </a:xfrm>
           <a:prstGeom prst="line">
             <a:avLst/>
@@ -4177,8 +3997,8 @@
         </p:nvCxnSpPr>
         <p:spPr>
           <a:xfrm>
-            <a:off x="6066816" y="3197366"/>
-            <a:ext cx="1773677" cy="0"/>
+            <a:off x="8164749" y="2776845"/>
+            <a:ext cx="1212715" cy="0"/>
           </a:xfrm>
           <a:prstGeom prst="line">
             <a:avLst/>
@@ -4206,9 +4026,9 @@
           <p:nvPr/>
         </p:nvCxnSpPr>
         <p:spPr>
-          <a:xfrm>
-            <a:off x="8164749" y="3205875"/>
-            <a:ext cx="2175753" cy="0"/>
+          <a:xfrm flipV="1">
+            <a:off x="6086271" y="3196147"/>
+            <a:ext cx="0" cy="532997"/>
           </a:xfrm>
           <a:prstGeom prst="line">
             <a:avLst/>
@@ -4236,9 +4056,9 @@
           <p:nvPr/>
         </p:nvCxnSpPr>
         <p:spPr>
-          <a:xfrm>
-            <a:off x="8164749" y="2776845"/>
-            <a:ext cx="1212715" cy="0"/>
+          <a:xfrm flipV="1">
+            <a:off x="5661497" y="2222162"/>
+            <a:ext cx="0" cy="375123"/>
           </a:xfrm>
           <a:prstGeom prst="line">
             <a:avLst/>
@@ -4267,7 +4087,7 @@
         </p:nvCxnSpPr>
         <p:spPr>
           <a:xfrm flipV="1">
-            <a:off x="6086271" y="3196147"/>
+            <a:off x="5371442" y="2243848"/>
             <a:ext cx="0" cy="532997"/>
           </a:xfrm>
           <a:prstGeom prst="line">
@@ -4292,66 +4112,6 @@
       <p:cxnSp>
         <p:nvCxnSpPr>
           <p:cNvPr id="19" name="Connector 18"/>
-          <p:cNvCxnSpPr/>
-          <p:nvPr/>
-        </p:nvCxnSpPr>
-        <p:spPr>
-          <a:xfrm flipV="1">
-            <a:off x="5661497" y="2222162"/>
-            <a:ext cx="0" cy="375123"/>
-          </a:xfrm>
-          <a:prstGeom prst="line">
-            <a:avLst/>
-          </a:prstGeom>
-        </p:spPr>
-        <p:style>
-          <a:lnRef idx="2">
-            <a:schemeClr val="accent1"/>
-          </a:lnRef>
-          <a:fillRef idx="0">
-            <a:schemeClr val="accent1"/>
-          </a:fillRef>
-          <a:effectRef idx="1">
-            <a:schemeClr val="accent1"/>
-          </a:effectRef>
-          <a:fontRef idx="minor">
-            <a:schemeClr val="tx1"/>
-          </a:fontRef>
-        </p:style>
-      </p:cxnSp>
-      <p:cxnSp>
-        <p:nvCxnSpPr>
-          <p:cNvPr id="20" name="Connector 19"/>
-          <p:cNvCxnSpPr/>
-          <p:nvPr/>
-        </p:nvCxnSpPr>
-        <p:spPr>
-          <a:xfrm flipV="1">
-            <a:off x="5371442" y="2243848"/>
-            <a:ext cx="0" cy="532997"/>
-          </a:xfrm>
-          <a:prstGeom prst="line">
-            <a:avLst/>
-          </a:prstGeom>
-        </p:spPr>
-        <p:style>
-          <a:lnRef idx="2">
-            <a:schemeClr val="accent1"/>
-          </a:lnRef>
-          <a:fillRef idx="0">
-            <a:schemeClr val="accent1"/>
-          </a:fillRef>
-          <a:effectRef idx="1">
-            <a:schemeClr val="accent1"/>
-          </a:effectRef>
-          <a:fontRef idx="minor">
-            <a:schemeClr val="tx1"/>
-          </a:fontRef>
-        </p:style>
-      </p:cxnSp>
-      <p:cxnSp>
-        <p:nvCxnSpPr>
-          <p:cNvPr id="21" name="Connector 20"/>
           <p:cNvCxnSpPr/>
           <p:nvPr/>
         </p:nvCxnSpPr>
@@ -4397,57 +4157,9 @@
         <p:nvPr/>
       </p:nvGrpSpPr>
       <p:grpSpPr/>
-      <p:pic>
-        <p:nvPicPr>
-          <p:cNvPr id="2" name="Picture 1" descr="image2.jpeg"/>
-          <p:cNvPicPr>
-            <a:picLocks noChangeAspect="1"/>
-          </p:cNvPicPr>
-          <p:nvPr/>
-        </p:nvPicPr>
-        <p:blipFill>
-          <a:blip r:embed="rId2"/>
-          <a:stretch>
-            <a:fillRect/>
-          </a:stretch>
-        </p:blipFill>
-        <p:spPr>
-          <a:xfrm>
-            <a:off x="188120" y="5525929"/>
-            <a:ext cx="1143000" cy="1224229"/>
-          </a:xfrm>
-          <a:prstGeom prst="rect">
-            <a:avLst/>
-          </a:prstGeom>
-        </p:spPr>
-      </p:pic>
-      <p:pic>
-        <p:nvPicPr>
-          <p:cNvPr id="3" name="Picture 2" descr="image3.jpg"/>
-          <p:cNvPicPr>
-            <a:picLocks noChangeAspect="1"/>
-          </p:cNvPicPr>
-          <p:nvPr/>
-        </p:nvPicPr>
-        <p:blipFill>
-          <a:blip r:embed="rId3"/>
-          <a:stretch>
-            <a:fillRect/>
-          </a:stretch>
-        </p:blipFill>
-        <p:spPr>
-          <a:xfrm>
-            <a:off x="10638881" y="139366"/>
-            <a:ext cx="1410420" cy="1371600"/>
-          </a:xfrm>
-          <a:prstGeom prst="rect">
-            <a:avLst/>
-          </a:prstGeom>
-        </p:spPr>
-      </p:pic>
-      <p:sp>
-        <p:nvSpPr>
-          <p:cNvPr id="4" name="Rectangle 3"/>
+      <p:sp>
+        <p:nvSpPr>
+          <p:cNvPr id="2" name="Rectangle 1"/>
           <p:cNvSpPr/>
           <p:nvPr/>
         </p:nvSpPr>
@@ -4486,7 +4198,7 @@
       </p:sp>
       <p:sp>
         <p:nvSpPr>
-          <p:cNvPr id="5" name="Rectangle 4"/>
+          <p:cNvPr id="3" name="Rectangle 2"/>
           <p:cNvSpPr/>
           <p:nvPr/>
         </p:nvSpPr>
@@ -4541,57 +4253,9 @@
         <p:nvPr/>
       </p:nvGrpSpPr>
       <p:grpSpPr/>
-      <p:pic>
-        <p:nvPicPr>
-          <p:cNvPr id="2" name="Picture 1" descr="image2.jpeg"/>
-          <p:cNvPicPr>
-            <a:picLocks noChangeAspect="1"/>
-          </p:cNvPicPr>
-          <p:nvPr/>
-        </p:nvPicPr>
-        <p:blipFill>
-          <a:blip r:embed="rId2"/>
-          <a:stretch>
-            <a:fillRect/>
-          </a:stretch>
-        </p:blipFill>
-        <p:spPr>
-          <a:xfrm>
-            <a:off x="188120" y="5525929"/>
-            <a:ext cx="1143000" cy="1224229"/>
-          </a:xfrm>
-          <a:prstGeom prst="rect">
-            <a:avLst/>
-          </a:prstGeom>
-        </p:spPr>
-      </p:pic>
-      <p:pic>
-        <p:nvPicPr>
-          <p:cNvPr id="3" name="Picture 2" descr="image3.jpg"/>
-          <p:cNvPicPr>
-            <a:picLocks noChangeAspect="1"/>
-          </p:cNvPicPr>
-          <p:nvPr/>
-        </p:nvPicPr>
-        <p:blipFill>
-          <a:blip r:embed="rId3"/>
-          <a:stretch>
-            <a:fillRect/>
-          </a:stretch>
-        </p:blipFill>
-        <p:spPr>
-          <a:xfrm>
-            <a:off x="10638881" y="139366"/>
-            <a:ext cx="1410420" cy="1371600"/>
-          </a:xfrm>
-          <a:prstGeom prst="rect">
-            <a:avLst/>
-          </a:prstGeom>
-        </p:spPr>
-      </p:pic>
-      <p:sp>
-        <p:nvSpPr>
-          <p:cNvPr id="4" name="Rectangle 3"/>
+      <p:sp>
+        <p:nvSpPr>
+          <p:cNvPr id="2" name="Rectangle 1"/>
           <p:cNvSpPr/>
           <p:nvPr/>
         </p:nvSpPr>
@@ -4630,7 +4294,7 @@
       </p:sp>
       <p:sp>
         <p:nvSpPr>
-          <p:cNvPr id="5" name="Rectangle 4"/>
+          <p:cNvPr id="3" name="Rectangle 2"/>
           <p:cNvSpPr/>
           <p:nvPr/>
         </p:nvSpPr>
@@ -4685,57 +4349,9 @@
         <p:nvPr/>
       </p:nvGrpSpPr>
       <p:grpSpPr/>
-      <p:pic>
-        <p:nvPicPr>
-          <p:cNvPr id="2" name="Picture 1" descr="image2.jpeg"/>
-          <p:cNvPicPr>
-            <a:picLocks noChangeAspect="1"/>
-          </p:cNvPicPr>
-          <p:nvPr/>
-        </p:nvPicPr>
-        <p:blipFill>
-          <a:blip r:embed="rId2"/>
-          <a:stretch>
-            <a:fillRect/>
-          </a:stretch>
-        </p:blipFill>
-        <p:spPr>
-          <a:xfrm>
-            <a:off x="188120" y="5525929"/>
-            <a:ext cx="1143000" cy="1224229"/>
-          </a:xfrm>
-          <a:prstGeom prst="rect">
-            <a:avLst/>
-          </a:prstGeom>
-        </p:spPr>
-      </p:pic>
-      <p:pic>
-        <p:nvPicPr>
-          <p:cNvPr id="3" name="Picture 2" descr="image3.jpg"/>
-          <p:cNvPicPr>
-            <a:picLocks noChangeAspect="1"/>
-          </p:cNvPicPr>
-          <p:nvPr/>
-        </p:nvPicPr>
-        <p:blipFill>
-          <a:blip r:embed="rId3"/>
-          <a:stretch>
-            <a:fillRect/>
-          </a:stretch>
-        </p:blipFill>
-        <p:spPr>
-          <a:xfrm>
-            <a:off x="10638881" y="139366"/>
-            <a:ext cx="1410420" cy="1371600"/>
-          </a:xfrm>
-          <a:prstGeom prst="rect">
-            <a:avLst/>
-          </a:prstGeom>
-        </p:spPr>
-      </p:pic>
-      <p:sp>
-        <p:nvSpPr>
-          <p:cNvPr id="4" name="Rectangle 3"/>
+      <p:sp>
+        <p:nvSpPr>
+          <p:cNvPr id="2" name="Rectangle 1"/>
           <p:cNvSpPr/>
           <p:nvPr/>
         </p:nvSpPr>
@@ -4774,7 +4390,7 @@
       </p:sp>
       <p:sp>
         <p:nvSpPr>
-          <p:cNvPr id="5" name="Rectangle 4"/>
+          <p:cNvPr id="3" name="Rectangle 2"/>
           <p:cNvSpPr/>
           <p:nvPr/>
         </p:nvSpPr>
@@ -4829,57 +4445,9 @@
         <p:nvPr/>
       </p:nvGrpSpPr>
       <p:grpSpPr/>
-      <p:pic>
-        <p:nvPicPr>
-          <p:cNvPr id="2" name="Picture 1" descr="image2.jpeg"/>
-          <p:cNvPicPr>
-            <a:picLocks noChangeAspect="1"/>
-          </p:cNvPicPr>
-          <p:nvPr/>
-        </p:nvPicPr>
-        <p:blipFill>
-          <a:blip r:embed="rId2"/>
-          <a:stretch>
-            <a:fillRect/>
-          </a:stretch>
-        </p:blipFill>
-        <p:spPr>
-          <a:xfrm>
-            <a:off x="188120" y="5525929"/>
-            <a:ext cx="1143000" cy="1224229"/>
-          </a:xfrm>
-          <a:prstGeom prst="rect">
-            <a:avLst/>
-          </a:prstGeom>
-        </p:spPr>
-      </p:pic>
-      <p:pic>
-        <p:nvPicPr>
-          <p:cNvPr id="3" name="Picture 2" descr="image3.jpg"/>
-          <p:cNvPicPr>
-            <a:picLocks noChangeAspect="1"/>
-          </p:cNvPicPr>
-          <p:nvPr/>
-        </p:nvPicPr>
-        <p:blipFill>
-          <a:blip r:embed="rId3"/>
-          <a:stretch>
-            <a:fillRect/>
-          </a:stretch>
-        </p:blipFill>
-        <p:spPr>
-          <a:xfrm>
-            <a:off x="10638881" y="139366"/>
-            <a:ext cx="1410420" cy="1371600"/>
-          </a:xfrm>
-          <a:prstGeom prst="rect">
-            <a:avLst/>
-          </a:prstGeom>
-        </p:spPr>
-      </p:pic>
-      <p:sp>
-        <p:nvSpPr>
-          <p:cNvPr id="4" name="Rectangle 3"/>
+      <p:sp>
+        <p:nvSpPr>
+          <p:cNvPr id="2" name="Rectangle 1"/>
           <p:cNvSpPr/>
           <p:nvPr/>
         </p:nvSpPr>
@@ -4918,7 +4486,7 @@
       </p:sp>
       <p:sp>
         <p:nvSpPr>
-          <p:cNvPr id="5" name="Rectangle 4"/>
+          <p:cNvPr id="3" name="Rectangle 2"/>
           <p:cNvSpPr/>
           <p:nvPr/>
         </p:nvSpPr>
@@ -4973,57 +4541,9 @@
         <p:nvPr/>
       </p:nvGrpSpPr>
       <p:grpSpPr/>
-      <p:pic>
-        <p:nvPicPr>
-          <p:cNvPr id="2" name="Picture 1" descr="image2.jpeg"/>
-          <p:cNvPicPr>
-            <a:picLocks noChangeAspect="1"/>
-          </p:cNvPicPr>
-          <p:nvPr/>
-        </p:nvPicPr>
-        <p:blipFill>
-          <a:blip r:embed="rId2"/>
-          <a:stretch>
-            <a:fillRect/>
-          </a:stretch>
-        </p:blipFill>
-        <p:spPr>
-          <a:xfrm>
-            <a:off x="188120" y="5525929"/>
-            <a:ext cx="1143000" cy="1224229"/>
-          </a:xfrm>
-          <a:prstGeom prst="rect">
-            <a:avLst/>
-          </a:prstGeom>
-        </p:spPr>
-      </p:pic>
-      <p:pic>
-        <p:nvPicPr>
-          <p:cNvPr id="3" name="Picture 2" descr="image3.jpg"/>
-          <p:cNvPicPr>
-            <a:picLocks noChangeAspect="1"/>
-          </p:cNvPicPr>
-          <p:nvPr/>
-        </p:nvPicPr>
-        <p:blipFill>
-          <a:blip r:embed="rId3"/>
-          <a:stretch>
-            <a:fillRect/>
-          </a:stretch>
-        </p:blipFill>
-        <p:spPr>
-          <a:xfrm>
-            <a:off x="10638881" y="139366"/>
-            <a:ext cx="1410420" cy="1371600"/>
-          </a:xfrm>
-          <a:prstGeom prst="rect">
-            <a:avLst/>
-          </a:prstGeom>
-        </p:spPr>
-      </p:pic>
-      <p:sp>
-        <p:nvSpPr>
-          <p:cNvPr id="4" name="Rectangle 3"/>
+      <p:sp>
+        <p:nvSpPr>
+          <p:cNvPr id="2" name="Rectangle 1"/>
           <p:cNvSpPr/>
           <p:nvPr/>
         </p:nvSpPr>
@@ -5062,7 +4582,7 @@
       </p:sp>
       <p:sp>
         <p:nvSpPr>
-          <p:cNvPr id="5" name="Rectangle 4"/>
+          <p:cNvPr id="3" name="Rectangle 2"/>
           <p:cNvSpPr/>
           <p:nvPr/>
         </p:nvSpPr>
@@ -5101,7 +4621,7 @@
       </p:sp>
       <p:sp>
         <p:nvSpPr>
-          <p:cNvPr id="6" name="Rectangle 5"/>
+          <p:cNvPr id="4" name="Rectangle 3"/>
           <p:cNvSpPr/>
           <p:nvPr/>
         </p:nvSpPr>

</xml_diff>

<commit_message>
Recreations: layout ph geom for Fairies and PARTIAL decks
</commit_message>
<xml_diff>
--- a/examples/recreations/03_Box_Secretary__ArtNonprofit_Info_Planning_Meeting_20201220/out_mat2ppt.pptx
+++ b/examples/recreations/03_Box_Secretary__ArtNonprofit_Info_Planning_Meeting_20201220/out_mat2ppt.pptx
@@ -3154,8 +3154,8 @@
         </p:nvSpPr>
         <p:spPr>
           <a:xfrm>
-            <a:off x="838200" y="365125"/>
-            <a:ext cx="10515600" cy="1325563"/>
+            <a:off x="1524000" y="1122363"/>
+            <a:ext cx="9144000" cy="2387600"/>
           </a:xfrm>
           <a:prstGeom prst="rect">
             <a:avLst/>
@@ -3193,8 +3193,8 @@
         </p:nvSpPr>
         <p:spPr>
           <a:xfrm>
-            <a:off x="838200" y="365125"/>
-            <a:ext cx="10515600" cy="1325563"/>
+            <a:off x="1524000" y="3602038"/>
+            <a:ext cx="9144000" cy="1655762"/>
           </a:xfrm>
           <a:prstGeom prst="rect">
             <a:avLst/>
@@ -3307,7 +3307,7 @@
         </p:nvSpPr>
         <p:spPr>
           <a:xfrm>
-            <a:off x="838200" y="365125"/>
+            <a:off x="493095" y="1226"/>
             <a:ext cx="10515600" cy="1325563"/>
           </a:xfrm>
           <a:prstGeom prst="rect">
@@ -3335,6 +3335,43 @@
             <a:r>
               <a:t>Resources</a:t>
             </a:r>
+          </a:p>
+        </p:txBody>
+      </p:sp>
+      <p:sp>
+        <p:nvSpPr>
+          <p:cNvPr id="3" name="Rectangle 2"/>
+          <p:cNvSpPr/>
+          <p:nvPr/>
+        </p:nvSpPr>
+        <p:spPr>
+          <a:xfrm>
+            <a:off x="493095" y="1432877"/>
+            <a:ext cx="10515600" cy="4351338"/>
+          </a:xfrm>
+          <a:prstGeom prst="rect">
+            <a:avLst/>
+          </a:prstGeom>
+        </p:spPr>
+        <p:style>
+          <a:lnRef idx="1">
+            <a:schemeClr val="accent1"/>
+          </a:lnRef>
+          <a:fillRef idx="3">
+            <a:schemeClr val="accent1"/>
+          </a:fillRef>
+          <a:effectRef idx="2">
+            <a:schemeClr val="accent1"/>
+          </a:effectRef>
+          <a:fontRef idx="minor">
+            <a:schemeClr val="lt1"/>
+          </a:fontRef>
+        </p:style>
+        <p:txBody>
+          <a:bodyPr rtlCol="0" anchor="ctr"/>
+          <a:lstStyle/>
+          <a:p>
+            <a:pPr algn="ctr"/>
           </a:p>
         </p:txBody>
       </p:sp>
@@ -3364,7 +3401,7 @@
         </p:nvSpPr>
         <p:spPr>
           <a:xfrm>
-            <a:off x="838200" y="365125"/>
+            <a:off x="493095" y="1226"/>
             <a:ext cx="10515600" cy="1325563"/>
           </a:xfrm>
           <a:prstGeom prst="rect">
@@ -3460,7 +3497,7 @@
         </p:nvSpPr>
         <p:spPr>
           <a:xfrm>
-            <a:off x="838200" y="365125"/>
+            <a:off x="493095" y="1226"/>
             <a:ext cx="10515600" cy="1325563"/>
           </a:xfrm>
           <a:prstGeom prst="rect">

</xml_diff>